<commit_message>
Replace PPT slide 3 with four live McMillan Woods page captures
Slide 3 now shows Home, About Us, Accountancy, and the June 2024
Malaysia e-invoice seminar (YGL-World speakers) so it matches the
public site. Week-1 partner decision updated with those names.

Co-authored-by: Manikantasaiv26 <Manikantasaiv26@users.noreply.github.com>
</commit_message>
<xml_diff>
--- a/docs/McMillan-Woods-E-Invoicing-Architecture-Plan.pptx
+++ b/docs/McMillan-Woods-E-Invoicing-Architecture-Plan.pptx
@@ -8240,7 +8240,7 @@
                 </a:solidFill>
                 <a:latin typeface="Calibri"/>
               </a:rPr>
-              <a:t>First jurisdiction</a:t>
+              <a:t>First jurisdiction — recommend Malaysia first</a:t>
             </a:r>
           </a:p>
         </p:txBody>
@@ -8273,7 +8273,7 @@
                 </a:solidFill>
                 <a:latin typeface="Calibri"/>
               </a:rPr>
-              <a:t>India GST or Malaysia MyInvois? Pick where the first paying clients sit.</a:t>
+              <a:t>Secretariat is in Petaling Jaya and McM already ran the MyInvois seminar with YGL. India GST is go-live #2 unless a named Indian pilot is signed this week.</a:t>
             </a:r>
           </a:p>
         </p:txBody>
@@ -8614,7 +8614,7 @@
                 </a:solidFill>
                 <a:latin typeface="Calibri"/>
               </a:rPr>
-              <a:t>Named partners</a:t>
+              <a:t>Named partners — answered from the site</a:t>
             </a:r>
           </a:p>
         </p:txBody>
@@ -8647,7 +8647,7 @@
                 </a:solidFill>
                 <a:latin typeface="Calibri"/>
               </a:rPr>
-              <a:t>Which GSP (India) and/or YGL (Malaysia). Contracts, not workshops.</a:t>
+              <a:t>Malaysia: YGL World is already on stage with McM (26 Jun 2024) — Yeap Kong Chean (CEO), Tay Hoay Leng (Tax Director), Yong Cheng Yew (Innovation Director), with Dato’ Seri Dr. Raymond Liew. India GSP still needs a signed contract.</a:t>
             </a:r>
           </a:p>
         </p:txBody>
@@ -12063,7 +12063,7 @@
                 </a:solidFill>
                 <a:latin typeface="Calibri"/>
               </a:rPr>
-              <a:t>McMillan Woods is not a software vendor. It is a global association of independent CA and advisory firms.</a:t>
+              <a:t>Synced to live pages on mcmillanwoods.com — Home, About Us, Accountancy, and the Malaysia e-invoice seminar.</a:t>
             </a:r>
           </a:p>
         </p:txBody>
@@ -12076,8 +12076,8 @@
         </p:nvSpPr>
         <p:spPr>
           <a:xfrm>
-            <a:off x="457200" y="1463040"/>
-            <a:ext cx="5577840" cy="2103120"/>
+            <a:off x="384048" y="1353312"/>
+            <a:ext cx="5650992" cy="2450592"/>
           </a:xfrm>
           <a:prstGeom prst="roundRect">
             <a:avLst>
@@ -12113,16 +12113,40 @@
           </a:p>
         </p:txBody>
       </p:sp>
-      <p:sp>
-        <p:nvSpPr>
-          <p:cNvPr id="10" name="Rectangle 9"/>
+      <p:pic>
+        <p:nvPicPr>
+          <p:cNvPr id="10" name="Picture 9" descr="01-homepage.jpg"/>
+          <p:cNvPicPr>
+            <a:picLocks noChangeAspect="1"/>
+          </p:cNvPicPr>
+          <p:nvPr/>
+        </p:nvPicPr>
+        <p:blipFill>
+          <a:blip r:embed="rId2"/>
+          <a:stretch>
+            <a:fillRect/>
+          </a:stretch>
+        </p:blipFill>
+        <p:spPr>
+          <a:xfrm>
+            <a:off x="429768" y="1399032"/>
+            <a:ext cx="5559552" cy="1847088"/>
+          </a:xfrm>
+          <a:prstGeom prst="rect">
+            <a:avLst/>
+          </a:prstGeom>
+        </p:spPr>
+      </p:pic>
+      <p:sp>
+        <p:nvSpPr>
+          <p:cNvPr id="11" name="Rectangle 10"/>
           <p:cNvSpPr/>
           <p:nvPr/>
         </p:nvSpPr>
         <p:spPr>
           <a:xfrm>
-            <a:off x="457200" y="1463040"/>
-            <a:ext cx="73152" cy="2103120"/>
+            <a:off x="384048" y="3273552"/>
+            <a:ext cx="5650992" cy="530352"/>
           </a:xfrm>
           <a:prstGeom prst="rect">
             <a:avLst/>
@@ -12158,47 +12182,14 @@
       </p:sp>
       <p:sp>
         <p:nvSpPr>
-          <p:cNvPr id="11" name="TextBox 10"/>
-          <p:cNvSpPr txBox="1"/>
-          <p:nvPr/>
-        </p:nvSpPr>
-        <p:spPr>
-          <a:xfrm>
-            <a:off x="658368" y="1572768"/>
-            <a:ext cx="5266944" cy="329184"/>
-          </a:xfrm>
-          <a:prstGeom prst="rect">
-            <a:avLst/>
-          </a:prstGeom>
-          <a:noFill/>
-        </p:spPr>
-        <p:txBody>
-          <a:bodyPr wrap="square" anchor="t"/>
-          <a:lstStyle/>
-          <a:p>
-            <a:pPr algn="l"/>
-            <a:r>
-              <a:rPr sz="1600" b="1" i="0">
-                <a:solidFill>
-                  <a:srgbClr val="8B1A1A"/>
-                </a:solidFill>
-                <a:latin typeface="Calibri"/>
-              </a:rPr>
-              <a:t>Independent firms</a:t>
-            </a:r>
-          </a:p>
-        </p:txBody>
-      </p:sp>
-      <p:sp>
-        <p:nvSpPr>
           <p:cNvPr id="12" name="TextBox 11"/>
           <p:cNvSpPr txBox="1"/>
           <p:nvPr/>
         </p:nvSpPr>
         <p:spPr>
           <a:xfrm>
-            <a:off x="658368" y="1901952"/>
-            <a:ext cx="5266944" cy="1572768"/>
+            <a:off x="493776" y="3291840"/>
+            <a:ext cx="5468112" cy="201168"/>
           </a:xfrm>
           <a:prstGeom prst="rect">
             <a:avLst/>
@@ -12206,33 +12197,65 @@
           <a:noFill/>
         </p:spPr>
         <p:txBody>
-          <a:bodyPr wrap="square">
-            <a:spAutoFit/>
-          </a:bodyPr>
-          <a:lstStyle/>
-          <a:p>
-            <a:r>
-              <a:rPr sz="1400" b="0" i="0">
-                <a:solidFill>
-                  <a:srgbClr val="2B2B2B"/>
+          <a:bodyPr wrap="square" anchor="t"/>
+          <a:lstStyle/>
+          <a:p>
+            <a:pPr algn="l"/>
+            <a:r>
+              <a:rPr sz="1100" b="1" i="0">
+                <a:solidFill>
+                  <a:srgbClr val="C4A35A"/>
                 </a:solidFill>
                 <a:latin typeface="Calibri"/>
               </a:rPr>
-              <a:t>No equity in each other. Firm A must never see Firm B’s invoices. Secretariat operates; it does not own client data.</a:t>
-            </a:r>
-          </a:p>
-        </p:txBody>
-      </p:sp>
-      <p:sp>
-        <p:nvSpPr>
-          <p:cNvPr id="13" name="Rounded Rectangle 12"/>
+              <a:t>1  ·  Home</a:t>
+            </a:r>
+          </a:p>
+        </p:txBody>
+      </p:sp>
+      <p:sp>
+        <p:nvSpPr>
+          <p:cNvPr id="13" name="TextBox 12"/>
+          <p:cNvSpPr txBox="1"/>
+          <p:nvPr/>
+        </p:nvSpPr>
+        <p:spPr>
+          <a:xfrm>
+            <a:off x="493776" y="3493008"/>
+            <a:ext cx="5468112" cy="292608"/>
+          </a:xfrm>
+          <a:prstGeom prst="rect">
+            <a:avLst/>
+          </a:prstGeom>
+          <a:noFill/>
+        </p:spPr>
+        <p:txBody>
+          <a:bodyPr wrap="square" anchor="t"/>
+          <a:lstStyle/>
+          <a:p>
+            <a:pPr algn="l"/>
+            <a:r>
+              <a:rPr sz="1000" b="0" i="0">
+                <a:solidFill>
+                  <a:srgbClr val="FFFFFF"/>
+                </a:solidFill>
+                <a:latin typeface="Calibri"/>
+              </a:rPr>
+              <a:t>Audit, Tax &amp; Advisory  ·  Founder President Dato’ Seri Dr. Raymond Liew  ·  Chairman Tan Sri Datuk Wira Dr. Hj. Mohd Shukor</a:t>
+            </a:r>
+          </a:p>
+        </p:txBody>
+      </p:sp>
+      <p:sp>
+        <p:nvSpPr>
+          <p:cNvPr id="14" name="Rounded Rectangle 13"/>
           <p:cNvSpPr/>
           <p:nvPr/>
         </p:nvSpPr>
         <p:spPr>
           <a:xfrm>
-            <a:off x="6263640" y="1463040"/>
-            <a:ext cx="5577840" cy="2103120"/>
+            <a:off x="6163056" y="1353312"/>
+            <a:ext cx="5650992" cy="2450592"/>
           </a:xfrm>
           <a:prstGeom prst="roundRect">
             <a:avLst>
@@ -12268,16 +12291,40 @@
           </a:p>
         </p:txBody>
       </p:sp>
-      <p:sp>
-        <p:nvSpPr>
-          <p:cNvPr id="14" name="Rectangle 13"/>
+      <p:pic>
+        <p:nvPicPr>
+          <p:cNvPr id="15" name="Picture 14" descr="02-about.jpg"/>
+          <p:cNvPicPr>
+            <a:picLocks noChangeAspect="1"/>
+          </p:cNvPicPr>
+          <p:nvPr/>
+        </p:nvPicPr>
+        <p:blipFill>
+          <a:blip r:embed="rId3"/>
+          <a:stretch>
+            <a:fillRect/>
+          </a:stretch>
+        </p:blipFill>
+        <p:spPr>
+          <a:xfrm>
+            <a:off x="6208776" y="1399032"/>
+            <a:ext cx="5559552" cy="1847088"/>
+          </a:xfrm>
+          <a:prstGeom prst="rect">
+            <a:avLst/>
+          </a:prstGeom>
+        </p:spPr>
+      </p:pic>
+      <p:sp>
+        <p:nvSpPr>
+          <p:cNvPr id="16" name="Rectangle 15"/>
           <p:cNvSpPr/>
           <p:nvPr/>
         </p:nvSpPr>
         <p:spPr>
           <a:xfrm>
-            <a:off x="6263640" y="1463040"/>
-            <a:ext cx="73152" cy="2103120"/>
+            <a:off x="6163056" y="3273552"/>
+            <a:ext cx="5650992" cy="530352"/>
           </a:xfrm>
           <a:prstGeom prst="rect">
             <a:avLst/>
@@ -12313,14 +12360,14 @@
       </p:sp>
       <p:sp>
         <p:nvSpPr>
-          <p:cNvPr id="15" name="TextBox 14"/>
+          <p:cNvPr id="17" name="TextBox 16"/>
           <p:cNvSpPr txBox="1"/>
           <p:nvPr/>
         </p:nvSpPr>
         <p:spPr>
           <a:xfrm>
-            <a:off x="6464808" y="1572768"/>
-            <a:ext cx="5266944" cy="329184"/>
+            <a:off x="6272784" y="3291840"/>
+            <a:ext cx="5468112" cy="201168"/>
           </a:xfrm>
           <a:prstGeom prst="rect">
             <a:avLst/>
@@ -12333,27 +12380,27 @@
           <a:p>
             <a:pPr algn="l"/>
             <a:r>
-              <a:rPr sz="1600" b="1" i="0">
-                <a:solidFill>
-                  <a:srgbClr val="8B1A1A"/>
+              <a:rPr sz="1100" b="1" i="0">
+                <a:solidFill>
+                  <a:srgbClr val="C4A35A"/>
                 </a:solidFill>
                 <a:latin typeface="Calibri"/>
               </a:rPr>
-              <a:t>Services already in house</a:t>
-            </a:r>
-          </a:p>
-        </p:txBody>
-      </p:sp>
-      <p:sp>
-        <p:nvSpPr>
-          <p:cNvPr id="16" name="TextBox 15"/>
+              <a:t>2  ·  About Us</a:t>
+            </a:r>
+          </a:p>
+        </p:txBody>
+      </p:sp>
+      <p:sp>
+        <p:nvSpPr>
+          <p:cNvPr id="18" name="TextBox 17"/>
           <p:cNvSpPr txBox="1"/>
           <p:nvPr/>
         </p:nvSpPr>
         <p:spPr>
           <a:xfrm>
-            <a:off x="6464808" y="1901952"/>
-            <a:ext cx="5266944" cy="1572768"/>
+            <a:off x="6272784" y="3493008"/>
+            <a:ext cx="5468112" cy="292608"/>
           </a:xfrm>
           <a:prstGeom prst="rect">
             <a:avLst/>
@@ -12361,33 +12408,32 @@
           <a:noFill/>
         </p:spPr>
         <p:txBody>
-          <a:bodyPr wrap="square">
-            <a:spAutoFit/>
-          </a:bodyPr>
-          <a:lstStyle/>
-          <a:p>
-            <a:r>
-              <a:rPr sz="1400" b="0" i="0">
-                <a:solidFill>
-                  <a:srgbClr val="2B2B2B"/>
+          <a:bodyPr wrap="square" anchor="t"/>
+          <a:lstStyle/>
+          <a:p>
+            <a:pPr algn="l"/>
+            <a:r>
+              <a:rPr sz="1000" b="0" i="0">
+                <a:solidFill>
+                  <a:srgbClr val="FFFFFF"/>
                 </a:solidFill>
                 <a:latin typeface="Calibri"/>
               </a:rPr>
-              <a:t>Bookkeeping, payroll, GST/VAT returns, outsourcing for start-ups and foreign-owned companies.</a:t>
-            </a:r>
-          </a:p>
-        </p:txBody>
-      </p:sp>
-      <p:sp>
-        <p:nvSpPr>
-          <p:cNvPr id="17" name="Rounded Rectangle 16"/>
+              <a:t>Global association of independent, qualified firms  ·  red / maroon / white / black identity  ·  not a software vendor</a:t>
+            </a:r>
+          </a:p>
+        </p:txBody>
+      </p:sp>
+      <p:sp>
+        <p:nvSpPr>
+          <p:cNvPr id="19" name="Rounded Rectangle 18"/>
           <p:cNvSpPr/>
           <p:nvPr/>
         </p:nvSpPr>
         <p:spPr>
           <a:xfrm>
-            <a:off x="457200" y="3749040"/>
-            <a:ext cx="5577840" cy="2103120"/>
+            <a:off x="384048" y="3913632"/>
+            <a:ext cx="5650992" cy="2450592"/>
           </a:xfrm>
           <a:prstGeom prst="roundRect">
             <a:avLst>
@@ -12423,16 +12469,218 @@
           </a:p>
         </p:txBody>
       </p:sp>
-      <p:sp>
-        <p:nvSpPr>
-          <p:cNvPr id="18" name="Rectangle 17"/>
+      <p:pic>
+        <p:nvPicPr>
+          <p:cNvPr id="20" name="Picture 19" descr="03-accountancy-services.jpg"/>
+          <p:cNvPicPr>
+            <a:picLocks noChangeAspect="1"/>
+          </p:cNvPicPr>
+          <p:nvPr/>
+        </p:nvPicPr>
+        <p:blipFill>
+          <a:blip r:embed="rId4"/>
+          <a:stretch>
+            <a:fillRect/>
+          </a:stretch>
+        </p:blipFill>
+        <p:spPr>
+          <a:xfrm>
+            <a:off x="429768" y="3959352"/>
+            <a:ext cx="5559552" cy="1847088"/>
+          </a:xfrm>
+          <a:prstGeom prst="rect">
+            <a:avLst/>
+          </a:prstGeom>
+        </p:spPr>
+      </p:pic>
+      <p:sp>
+        <p:nvSpPr>
+          <p:cNvPr id="21" name="Rectangle 20"/>
           <p:cNvSpPr/>
           <p:nvPr/>
         </p:nvSpPr>
         <p:spPr>
           <a:xfrm>
-            <a:off x="457200" y="3749040"/>
-            <a:ext cx="73152" cy="2103120"/>
+            <a:off x="384048" y="5833872"/>
+            <a:ext cx="5650992" cy="530352"/>
+          </a:xfrm>
+          <a:prstGeom prst="rect">
+            <a:avLst/>
+          </a:prstGeom>
+          <a:solidFill>
+            <a:srgbClr val="5C0F12"/>
+          </a:solidFill>
+          <a:ln>
+            <a:noFill/>
+          </a:ln>
+        </p:spPr>
+        <p:style>
+          <a:lnRef idx="1">
+            <a:schemeClr val="accent1"/>
+          </a:lnRef>
+          <a:fillRef idx="3">
+            <a:schemeClr val="accent1"/>
+          </a:fillRef>
+          <a:effectRef idx="2">
+            <a:schemeClr val="accent1"/>
+          </a:effectRef>
+          <a:fontRef idx="minor">
+            <a:schemeClr val="lt1"/>
+          </a:fontRef>
+        </p:style>
+        <p:txBody>
+          <a:bodyPr rtlCol="0" anchor="ctr"/>
+          <a:lstStyle/>
+          <a:p>
+            <a:pPr algn="ctr"/>
+          </a:p>
+        </p:txBody>
+      </p:sp>
+      <p:sp>
+        <p:nvSpPr>
+          <p:cNvPr id="22" name="TextBox 21"/>
+          <p:cNvSpPr txBox="1"/>
+          <p:nvPr/>
+        </p:nvSpPr>
+        <p:spPr>
+          <a:xfrm>
+            <a:off x="493776" y="5852160"/>
+            <a:ext cx="5468112" cy="201168"/>
+          </a:xfrm>
+          <a:prstGeom prst="rect">
+            <a:avLst/>
+          </a:prstGeom>
+          <a:noFill/>
+        </p:spPr>
+        <p:txBody>
+          <a:bodyPr wrap="square" anchor="t"/>
+          <a:lstStyle/>
+          <a:p>
+            <a:pPr algn="l"/>
+            <a:r>
+              <a:rPr sz="1100" b="1" i="0">
+                <a:solidFill>
+                  <a:srgbClr val="C4A35A"/>
+                </a:solidFill>
+                <a:latin typeface="Calibri"/>
+              </a:rPr>
+              <a:t>3  ·  Accountancy</a:t>
+            </a:r>
+          </a:p>
+        </p:txBody>
+      </p:sp>
+      <p:sp>
+        <p:nvSpPr>
+          <p:cNvPr id="23" name="TextBox 22"/>
+          <p:cNvSpPr txBox="1"/>
+          <p:nvPr/>
+        </p:nvSpPr>
+        <p:spPr>
+          <a:xfrm>
+            <a:off x="493776" y="6053328"/>
+            <a:ext cx="5468112" cy="292608"/>
+          </a:xfrm>
+          <a:prstGeom prst="rect">
+            <a:avLst/>
+          </a:prstGeom>
+          <a:noFill/>
+        </p:spPr>
+        <p:txBody>
+          <a:bodyPr wrap="square" anchor="t"/>
+          <a:lstStyle/>
+          <a:p>
+            <a:pPr algn="l"/>
+            <a:r>
+              <a:rPr sz="1000" b="0" i="0">
+                <a:solidFill>
+                  <a:srgbClr val="FFFFFF"/>
+                </a:solidFill>
+                <a:latin typeface="Calibri"/>
+              </a:rPr>
+              <a:t>Book-keeping  ·  Payroll (urgent weekly/monthly)  ·  Management accounts  ·  Annual reports</a:t>
+            </a:r>
+          </a:p>
+        </p:txBody>
+      </p:sp>
+      <p:sp>
+        <p:nvSpPr>
+          <p:cNvPr id="24" name="Rounded Rectangle 23"/>
+          <p:cNvSpPr/>
+          <p:nvPr/>
+        </p:nvSpPr>
+        <p:spPr>
+          <a:xfrm>
+            <a:off x="6163056" y="3913632"/>
+            <a:ext cx="5650992" cy="2450592"/>
+          </a:xfrm>
+          <a:prstGeom prst="roundRect">
+            <a:avLst>
+              <a:gd name="adj" fmla="val 8000"/>
+            </a:avLst>
+          </a:prstGeom>
+          <a:solidFill>
+            <a:srgbClr val="FFFFFF"/>
+          </a:solidFill>
+          <a:ln>
+            <a:noFill/>
+          </a:ln>
+        </p:spPr>
+        <p:style>
+          <a:lnRef idx="1">
+            <a:schemeClr val="accent1"/>
+          </a:lnRef>
+          <a:fillRef idx="3">
+            <a:schemeClr val="accent1"/>
+          </a:fillRef>
+          <a:effectRef idx="2">
+            <a:schemeClr val="accent1"/>
+          </a:effectRef>
+          <a:fontRef idx="minor">
+            <a:schemeClr val="lt1"/>
+          </a:fontRef>
+        </p:style>
+        <p:txBody>
+          <a:bodyPr rtlCol="0" anchor="ctr"/>
+          <a:lstStyle/>
+          <a:p>
+            <a:pPr algn="ctr"/>
+          </a:p>
+        </p:txBody>
+      </p:sp>
+      <p:pic>
+        <p:nvPicPr>
+          <p:cNvPr id="25" name="Picture 24" descr="04-malaysia-einvoice.jpg"/>
+          <p:cNvPicPr>
+            <a:picLocks noChangeAspect="1"/>
+          </p:cNvPicPr>
+          <p:nvPr/>
+        </p:nvPicPr>
+        <p:blipFill>
+          <a:blip r:embed="rId5"/>
+          <a:stretch>
+            <a:fillRect/>
+          </a:stretch>
+        </p:blipFill>
+        <p:spPr>
+          <a:xfrm>
+            <a:off x="6208776" y="3959352"/>
+            <a:ext cx="5559552" cy="1847088"/>
+          </a:xfrm>
+          <a:prstGeom prst="rect">
+            <a:avLst/>
+          </a:prstGeom>
+        </p:spPr>
+      </p:pic>
+      <p:sp>
+        <p:nvSpPr>
+          <p:cNvPr id="26" name="Rectangle 25"/>
+          <p:cNvSpPr/>
+          <p:nvPr/>
+        </p:nvSpPr>
+        <p:spPr>
+          <a:xfrm>
+            <a:off x="6163056" y="5833872"/>
+            <a:ext cx="5650992" cy="530352"/>
           </a:xfrm>
           <a:prstGeom prst="rect">
             <a:avLst/>
@@ -12468,14 +12716,14 @@
       </p:sp>
       <p:sp>
         <p:nvSpPr>
-          <p:cNvPr id="19" name="TextBox 18"/>
+          <p:cNvPr id="27" name="TextBox 26"/>
           <p:cNvSpPr txBox="1"/>
           <p:nvPr/>
         </p:nvSpPr>
         <p:spPr>
           <a:xfrm>
-            <a:off x="658368" y="3858768"/>
-            <a:ext cx="5266944" cy="329184"/>
+            <a:off x="6272784" y="5852160"/>
+            <a:ext cx="5468112" cy="201168"/>
           </a:xfrm>
           <a:prstGeom prst="rect">
             <a:avLst/>
@@ -12488,27 +12736,27 @@
           <a:p>
             <a:pPr algn="l"/>
             <a:r>
-              <a:rPr sz="1600" b="1" i="0">
-                <a:solidFill>
-                  <a:srgbClr val="8B1A1A"/>
+              <a:rPr sz="1100" b="1" i="0">
+                <a:solidFill>
+                  <a:srgbClr val="C4A35A"/>
                 </a:solidFill>
                 <a:latin typeface="Calibri"/>
               </a:rPr>
-              <a:t>ERP reality</a:t>
-            </a:r>
-          </a:p>
-        </p:txBody>
-      </p:sp>
-      <p:sp>
-        <p:nvSpPr>
-          <p:cNvPr id="20" name="TextBox 19"/>
+              <a:t>4  ·  Events  ·  YGL-World</a:t>
+            </a:r>
+          </a:p>
+        </p:txBody>
+      </p:sp>
+      <p:sp>
+        <p:nvSpPr>
+          <p:cNvPr id="28" name="TextBox 27"/>
           <p:cNvSpPr txBox="1"/>
           <p:nvPr/>
         </p:nvSpPr>
         <p:spPr>
           <a:xfrm>
-            <a:off x="658368" y="4187952"/>
-            <a:ext cx="5266944" cy="1572768"/>
+            <a:off x="6272784" y="6053328"/>
+            <a:ext cx="5468112" cy="292608"/>
           </a:xfrm>
           <a:prstGeom prst="rect">
             <a:avLst/>
@@ -12516,181 +12764,25 @@
           <a:noFill/>
         </p:spPr>
         <p:txBody>
-          <a:bodyPr wrap="square">
-            <a:spAutoFit/>
-          </a:bodyPr>
-          <a:lstStyle/>
-          <a:p>
-            <a:r>
-              <a:rPr sz="1400" b="0" i="0">
-                <a:solidFill>
-                  <a:srgbClr val="2B2B2B"/>
+          <a:bodyPr wrap="square" anchor="t"/>
+          <a:lstStyle/>
+          <a:p>
+            <a:pPr algn="l"/>
+            <a:r>
+              <a:rPr sz="1000" b="0" i="0">
+                <a:solidFill>
+                  <a:srgbClr val="FFFFFF"/>
                 </a:solidFill>
                 <a:latin typeface="Calibri"/>
               </a:rPr>
-              <a:t>Member firms already sit on Tally, SAP, Dynamics, Xero, QuickBooks — connectors are first-class work, not an afterthought.</a:t>
-            </a:r>
-          </a:p>
-        </p:txBody>
-      </p:sp>
-      <p:sp>
-        <p:nvSpPr>
-          <p:cNvPr id="21" name="Rounded Rectangle 20"/>
-          <p:cNvSpPr/>
-          <p:nvPr/>
-        </p:nvSpPr>
-        <p:spPr>
-          <a:xfrm>
-            <a:off x="6263640" y="3749040"/>
-            <a:ext cx="5577840" cy="2103120"/>
-          </a:xfrm>
-          <a:prstGeom prst="roundRect">
-            <a:avLst>
-              <a:gd name="adj" fmla="val 8000"/>
-            </a:avLst>
-          </a:prstGeom>
-          <a:solidFill>
-            <a:srgbClr val="FFFFFF"/>
-          </a:solidFill>
-          <a:ln>
-            <a:noFill/>
-          </a:ln>
-        </p:spPr>
-        <p:style>
-          <a:lnRef idx="1">
-            <a:schemeClr val="accent1"/>
-          </a:lnRef>
-          <a:fillRef idx="3">
-            <a:schemeClr val="accent1"/>
-          </a:fillRef>
-          <a:effectRef idx="2">
-            <a:schemeClr val="accent1"/>
-          </a:effectRef>
-          <a:fontRef idx="minor">
-            <a:schemeClr val="lt1"/>
-          </a:fontRef>
-        </p:style>
-        <p:txBody>
-          <a:bodyPr rtlCol="0" anchor="ctr"/>
-          <a:lstStyle/>
-          <a:p>
-            <a:pPr algn="ctr"/>
-          </a:p>
-        </p:txBody>
-      </p:sp>
-      <p:sp>
-        <p:nvSpPr>
-          <p:cNvPr id="22" name="Rectangle 21"/>
-          <p:cNvSpPr/>
-          <p:nvPr/>
-        </p:nvSpPr>
-        <p:spPr>
-          <a:xfrm>
-            <a:off x="6263640" y="3749040"/>
-            <a:ext cx="73152" cy="2103120"/>
-          </a:xfrm>
-          <a:prstGeom prst="rect">
-            <a:avLst/>
-          </a:prstGeom>
-          <a:solidFill>
-            <a:srgbClr val="8B1A1A"/>
-          </a:solidFill>
-          <a:ln>
-            <a:noFill/>
-          </a:ln>
-        </p:spPr>
-        <p:style>
-          <a:lnRef idx="1">
-            <a:schemeClr val="accent1"/>
-          </a:lnRef>
-          <a:fillRef idx="3">
-            <a:schemeClr val="accent1"/>
-          </a:fillRef>
-          <a:effectRef idx="2">
-            <a:schemeClr val="accent1"/>
-          </a:effectRef>
-          <a:fontRef idx="minor">
-            <a:schemeClr val="lt1"/>
-          </a:fontRef>
-        </p:style>
-        <p:txBody>
-          <a:bodyPr rtlCol="0" anchor="ctr"/>
-          <a:lstStyle/>
-          <a:p>
-            <a:pPr algn="ctr"/>
-          </a:p>
-        </p:txBody>
-      </p:sp>
-      <p:sp>
-        <p:nvSpPr>
-          <p:cNvPr id="23" name="TextBox 22"/>
-          <p:cNvSpPr txBox="1"/>
-          <p:nvPr/>
-        </p:nvSpPr>
-        <p:spPr>
-          <a:xfrm>
-            <a:off x="6464808" y="3858768"/>
-            <a:ext cx="5266944" cy="329184"/>
-          </a:xfrm>
-          <a:prstGeom prst="rect">
-            <a:avLst/>
-          </a:prstGeom>
-          <a:noFill/>
-        </p:spPr>
-        <p:txBody>
-          <a:bodyPr wrap="square" anchor="t"/>
-          <a:lstStyle/>
-          <a:p>
-            <a:pPr algn="l"/>
-            <a:r>
-              <a:rPr sz="1600" b="1" i="0">
-                <a:solidFill>
-                  <a:srgbClr val="8B1A1A"/>
-                </a:solidFill>
-                <a:latin typeface="Calibri"/>
-              </a:rPr>
-              <a:t>Malaysia head-start</a:t>
-            </a:r>
-          </a:p>
-        </p:txBody>
-      </p:sp>
-      <p:sp>
-        <p:nvSpPr>
-          <p:cNvPr id="24" name="TextBox 23"/>
-          <p:cNvSpPr txBox="1"/>
-          <p:nvPr/>
-        </p:nvSpPr>
-        <p:spPr>
-          <a:xfrm>
-            <a:off x="6464808" y="4187952"/>
-            <a:ext cx="5266944" cy="1572768"/>
-          </a:xfrm>
-          <a:prstGeom prst="rect">
-            <a:avLst/>
-          </a:prstGeom>
-          <a:noFill/>
-        </p:spPr>
-        <p:txBody>
-          <a:bodyPr wrap="square">
-            <a:spAutoFit/>
-          </a:bodyPr>
-          <a:lstStyle/>
-          <a:p>
-            <a:r>
-              <a:rPr sz="1400" b="0" i="0">
-                <a:solidFill>
-                  <a:srgbClr val="2B2B2B"/>
-                </a:solidFill>
-                <a:latin typeface="Calibri"/>
-              </a:rPr>
-              <a:t>June 2024 seminar “Beyond e-Invoice Compliance in Malaysia” with YGL-World. Wrap partners; do not rebuild them on Day 1.</a:t>
-            </a:r>
-          </a:p>
-        </p:txBody>
-      </p:sp>
-      <p:sp>
-        <p:nvSpPr>
-          <p:cNvPr id="25" name="Rectangle 24"/>
+              <a:t>Beyond e-Invoice Compliance in Malaysia  ·  26 Jun 2024  ·  four speakers: Raymond Liew, Yeap Kong Chean, Tay Hoay Leng, Yong Cheng Yew</a:t>
+            </a:r>
+          </a:p>
+        </p:txBody>
+      </p:sp>
+      <p:sp>
+        <p:nvSpPr>
+          <p:cNvPr id="29" name="Rectangle 28"/>
           <p:cNvSpPr/>
           <p:nvPr/>
         </p:nvSpPr>
@@ -12733,7 +12825,7 @@
       </p:sp>
       <p:sp>
         <p:nvSpPr>
-          <p:cNvPr id="26" name="TextBox 25"/>
+          <p:cNvPr id="30" name="TextBox 29"/>
           <p:cNvSpPr txBox="1"/>
           <p:nvPr/>
         </p:nvSpPr>
@@ -12766,7 +12858,7 @@
       </p:sp>
       <p:sp>
         <p:nvSpPr>
-          <p:cNvPr id="27" name="TextBox 26"/>
+          <p:cNvPr id="31" name="TextBox 30"/>
           <p:cNvSpPr txBox="1"/>
           <p:nvPr/>
         </p:nvSpPr>

</xml_diff>